<commit_message>
feat: financial dashboard tab layout + dedup charts + AI follow-up conversation
- Add grouped sidebar Tab navigation to FinancialDashboardPBI (Tab/Grid toggle)
- Remove 6 charts duplicated with other pages (kpi_scorecard, expense_yoy_budget,
  gross_margin_trend, product_ranking, ar_aging, variance_analysis)
- Regroup remaining 12 charts into 4 groups + conclusions tab
- Add AI analysis follow-up conversation (multi-turn dialog per chart)
- Backend: AnalyzeRequest supports follow_up_question + previous_analysis
- Auto-trigger AI analysis on tab switch, always-visible analysis card
- SmartBI chart builders, iOS AIAgent rename, RN logistics module, i18n updates

Co-Authored-By: Claude Opus 4.6 (1M context) <noreply@anthropic.com>
</commit_message>
<xml_diff>
--- a/.playwright-mcp/财务分析看板-2026.pptx
+++ b/.playwright-mcp/财务分析看板-2026.pptx
@@ -3560,6 +3560,124 @@
           </a:prstGeom>
         </p:spPr>
       </p:pic>
+      <p:sp>
+        <p:nvSpPr>
+          <p:cNvPr id="4" name="TextBox 3"/>
+          <p:cNvSpPr txBox="1"/>
+          <p:nvPr/>
+        </p:nvSpPr>
+        <p:spPr>
+          <a:xfrm>
+            <a:off x="8229600" y="914400"/>
+            <a:ext cx="3657600" cy="457200"/>
+          </a:xfrm>
+          <a:prstGeom prst="rect">
+            <a:avLst/>
+          </a:prstGeom>
+          <a:noFill/>
+        </p:spPr>
+        <p:txBody>
+          <a:bodyPr wrap="square">
+            <a:spAutoFit/>
+          </a:bodyPr>
+          <a:lstStyle/>
+          <a:p>
+            <a:pPr>
+              <a:defRPr sz="1600" b="1">
+                <a:solidFill>
+                  <a:srgbClr val="1B65A8"/>
+                </a:solidFill>
+                <a:latin typeface="微软雅黑"/>
+              </a:defRPr>
+            </a:pPr>
+            <a:r>
+              <a:t>AI 分析</a:t>
+            </a:r>
+          </a:p>
+        </p:txBody>
+      </p:sp>
+      <p:sp>
+        <p:nvSpPr>
+          <p:cNvPr id="5" name="TextBox 4"/>
+          <p:cNvSpPr txBox="1"/>
+          <p:nvPr/>
+        </p:nvSpPr>
+        <p:spPr>
+          <a:xfrm>
+            <a:off x="8229600" y="1463040"/>
+            <a:ext cx="3657600" cy="4572000"/>
+          </a:xfrm>
+          <a:prstGeom prst="rect">
+            <a:avLst/>
+          </a:prstGeom>
+          <a:noFill/>
+        </p:spPr>
+        <p:txBody>
+          <a:bodyPr wrap="square">
+            <a:spAutoFit/>
+          </a:bodyPr>
+          <a:lstStyle/>
+          <a:p>
+            <a:pPr>
+              <a:defRPr sz="1100" b="0">
+                <a:solidFill>
+                  <a:srgbClr val="2C3E50"/>
+                </a:solidFill>
+                <a:latin typeface="微软雅黑"/>
+              </a:defRPr>
+            </a:pPr>
+            <a:r>
+              <a:t>### 1. 核心发现</a:t>
+            </a:r>
+            <a:br/>
+            <a:r>
+              <a:t>*   **预算执行精准**：预算达成率 99.3%，表明年初预算编制充分覆盖了业务增长预期，且期末管控严格，无超支现象。</a:t>
+            </a:r>
+            <a:br/>
+            <a:r>
+              <a:t>*   **费用增速显著**：同比增幅达 30.7%，远高于行业常规通胀水平，需确认是否由产能扩张、原料涨价或合规升级驱动。</a:t>
+            </a:r>
+            <a:br/>
+            <a:r>
+              <a:t>*   **成本结构变化**：绝对值 6.57 万元虽低（推测为特定部门或项目），但 1.54 万元的增量在局部成本中占比重大，需关注其对单品成本的传导影响。</a:t>
+            </a:r>
+            <a:br/>
+            <a:br/>
+            <a:r>
+              <a:t>### 2. 风险预警</a:t>
+            </a:r>
+            <a:br/>
+            <a:r>
+              <a:t>*   **投入产出错配**：若营收或产量未同步增长 30%，该费用中心的边际贡献将下降，直接侵蚀加工环节毛利率。</a:t>
+            </a:r>
+            <a:br/>
+            <a:r>
+              <a:t>*   **刚性成本固化**：若增长源于人力、租金或长期维保等固定费用，未来下调空间有限，将削弱企业应对市场波动的弹性。</a:t>
+            </a:r>
+            <a:br/>
+            <a:r>
+              <a:t>*   **合规性支出波动**：食品加工行业受监管影响大，需警惕新增质检、认证等一次性合规成本被误判为常态化运营费用。</a:t>
+            </a:r>
+            <a:br/>
+            <a:br/>
+            <a:r>
+              <a:t>### 3. 改进建议</a:t>
+            </a:r>
+            <a:br/>
+            <a:r>
+              <a:t>*   **开展动因穿透分析**：将 30.7% 增量拆解至具体科目（如包材、能耗、人工），区分“业务驱动型”与“政策驱动型”支出。</a:t>
+            </a:r>
+            <a:br/>
+            <a:r>
+              <a:t>*   **实施弹性预算机制**：明年预算不再简单基于历史数据，应引入产量/销量系数，实现费用与业务规模的动态挂钩。</a:t>
+            </a:r>
+            <a:br/>
+            <a:r>
+              <a:t>*   **建立专项效能评估**：针对高增长科目进行 ROI 测算，例如对比新增检测费用与客诉率降低幅度，确保每一分投入均有业务价值支撑。</a:t>
+            </a:r>
+          </a:p>
+        </p:txBody>
+      </p:sp>
     </p:spTree>
   </p:cSld>
   <p:clrMapOvr>

</xml_diff>